<commit_message>
SSLC r5 print: near-white panels (black on white)
</commit_message>
<xml_diff>
--- a/drafts/Exos_SSLC_Board_Offer_Overview_2026-10-12_r5_PRINT.pptx
+++ b/drafts/Exos_SSLC_Board_Offer_Overview_2026-10-12_r5_PRINT.pptx
@@ -2438,7 +2438,7 @@
             <a:avLst/>
           </a:prstGeom>
           <a:solidFill>
-            <a:srgbClr val="F3DDCF"/>
+            <a:srgbClr val="F9F1EC"/>
           </a:solidFill>
           <a:ln w="12700">
             <a:solidFill>
@@ -2506,7 +2506,7 @@
             <a:avLst/>
           </a:prstGeom>
           <a:solidFill>
-            <a:srgbClr val="F3DDCF"/>
+            <a:srgbClr val="F9F1EC"/>
           </a:solidFill>
           <a:ln w="12700">
             <a:solidFill>
@@ -2574,7 +2574,7 @@
             <a:avLst/>
           </a:prstGeom>
           <a:solidFill>
-            <a:srgbClr val="F3DDCF"/>
+            <a:srgbClr val="F9F1EC"/>
           </a:solidFill>
           <a:ln w="12700">
             <a:solidFill>
@@ -2642,7 +2642,7 @@
             <a:avLst/>
           </a:prstGeom>
           <a:solidFill>
-            <a:srgbClr val="F3DDCF"/>
+            <a:srgbClr val="F9F1EC"/>
           </a:solidFill>
           <a:ln w="12700">
             <a:solidFill>
@@ -2710,7 +2710,7 @@
             <a:avLst/>
           </a:prstGeom>
           <a:solidFill>
-            <a:srgbClr val="F3DDCF"/>
+            <a:srgbClr val="F9F1EC"/>
           </a:solidFill>
           <a:ln w="12700">
             <a:solidFill>
@@ -2778,7 +2778,7 @@
             <a:avLst/>
           </a:prstGeom>
           <a:solidFill>
-            <a:srgbClr val="F3DDCF"/>
+            <a:srgbClr val="F9F1EC"/>
           </a:solidFill>
           <a:ln w="12700">
             <a:solidFill>
@@ -2846,7 +2846,7 @@
             <a:avLst/>
           </a:prstGeom>
           <a:solidFill>
-            <a:srgbClr val="EEEEEE"/>
+            <a:srgbClr val="F7F7F7"/>
           </a:solidFill>
           <a:ln w="12700">
             <a:solidFill>
@@ -2928,7 +2928,7 @@
             <a:avLst/>
           </a:prstGeom>
           <a:solidFill>
-            <a:srgbClr val="EEEEEE"/>
+            <a:srgbClr val="F7F7F7"/>
           </a:solidFill>
           <a:ln w="12700">
             <a:solidFill>
@@ -3010,7 +3010,7 @@
             <a:avLst/>
           </a:prstGeom>
           <a:solidFill>
-            <a:srgbClr val="EEEEEE"/>
+            <a:srgbClr val="F7F7F7"/>
           </a:solidFill>
           <a:ln w="12700">
             <a:solidFill>
@@ -3106,7 +3106,7 @@
             <a:avLst/>
           </a:prstGeom>
           <a:solidFill>
-            <a:srgbClr val="EEEEEE"/>
+            <a:srgbClr val="F7F7F7"/>
           </a:solidFill>
           <a:ln w="12700">
             <a:solidFill>
@@ -3202,7 +3202,7 @@
             <a:avLst/>
           </a:prstGeom>
           <a:solidFill>
-            <a:srgbClr val="EEEEEE"/>
+            <a:srgbClr val="F7F7F7"/>
           </a:solidFill>
           <a:ln w="12700">
             <a:solidFill>
@@ -3298,7 +3298,7 @@
             <a:avLst/>
           </a:prstGeom>
           <a:solidFill>
-            <a:srgbClr val="EEEEEE"/>
+            <a:srgbClr val="F7F7F7"/>
           </a:solidFill>
           <a:ln w="12700">
             <a:solidFill>
@@ -3380,7 +3380,7 @@
             <a:avLst/>
           </a:prstGeom>
           <a:solidFill>
-            <a:srgbClr val="D2D7E9"/>
+            <a:srgbClr val="EEF0F7"/>
           </a:solidFill>
           <a:ln w="12700">
             <a:solidFill>
@@ -3448,7 +3448,7 @@
             <a:avLst/>
           </a:prstGeom>
           <a:solidFill>
-            <a:srgbClr val="D2D7E9"/>
+            <a:srgbClr val="EEF0F7"/>
           </a:solidFill>
           <a:ln w="12700">
             <a:solidFill>
@@ -3516,7 +3516,7 @@
             <a:avLst/>
           </a:prstGeom>
           <a:solidFill>
-            <a:srgbClr val="D2D7E9"/>
+            <a:srgbClr val="EEF0F7"/>
           </a:solidFill>
           <a:ln w="12700">
             <a:solidFill>
@@ -3584,7 +3584,7 @@
             <a:avLst/>
           </a:prstGeom>
           <a:solidFill>
-            <a:srgbClr val="D2D7E9"/>
+            <a:srgbClr val="EEF0F7"/>
           </a:solidFill>
           <a:ln w="12700">
             <a:solidFill>
@@ -3652,7 +3652,7 @@
             <a:avLst/>
           </a:prstGeom>
           <a:solidFill>
-            <a:srgbClr val="D2D7E9"/>
+            <a:srgbClr val="EEF0F7"/>
           </a:solidFill>
           <a:ln w="12700">
             <a:solidFill>
@@ -3720,7 +3720,7 @@
             <a:avLst/>
           </a:prstGeom>
           <a:solidFill>
-            <a:srgbClr val="D2D7E9"/>
+            <a:srgbClr val="EEF0F7"/>
           </a:solidFill>
           <a:ln w="12700">
             <a:solidFill>
@@ -3788,7 +3788,7 @@
             <a:avLst/>
           </a:prstGeom>
           <a:solidFill>
-            <a:srgbClr val="EEEEEE"/>
+            <a:srgbClr val="F7F7F7"/>
           </a:solidFill>
           <a:ln w="12700">
             <a:solidFill>
@@ -3856,7 +3856,7 @@
             <a:avLst/>
           </a:prstGeom>
           <a:solidFill>
-            <a:srgbClr val="EEEEEE"/>
+            <a:srgbClr val="F7F7F7"/>
           </a:solidFill>
           <a:ln w="12700">
             <a:solidFill>
@@ -3924,7 +3924,7 @@
             <a:avLst/>
           </a:prstGeom>
           <a:solidFill>
-            <a:srgbClr val="EEEEEE"/>
+            <a:srgbClr val="F7F7F7"/>
           </a:solidFill>
           <a:ln w="12700">
             <a:solidFill>
@@ -3992,7 +3992,7 @@
             <a:avLst/>
           </a:prstGeom>
           <a:solidFill>
-            <a:srgbClr val="EEEEEE"/>
+            <a:srgbClr val="F7F7F7"/>
           </a:solidFill>
           <a:ln w="12700">
             <a:solidFill>
@@ -4060,7 +4060,7 @@
             <a:avLst/>
           </a:prstGeom>
           <a:solidFill>
-            <a:srgbClr val="EEEEEE"/>
+            <a:srgbClr val="F7F7F7"/>
           </a:solidFill>
           <a:ln w="12700">
             <a:solidFill>
@@ -4128,7 +4128,7 @@
             <a:avLst/>
           </a:prstGeom>
           <a:solidFill>
-            <a:srgbClr val="EEEEEE"/>
+            <a:srgbClr val="F7F7F7"/>
           </a:solidFill>
           <a:ln w="12700">
             <a:solidFill>
@@ -4196,7 +4196,7 @@
             <a:avLst/>
           </a:prstGeom>
           <a:solidFill>
-            <a:srgbClr val="D2D7E9"/>
+            <a:srgbClr val="EEF0F7"/>
           </a:solidFill>
           <a:ln w="12700">
             <a:solidFill>
@@ -4264,7 +4264,7 @@
             <a:avLst/>
           </a:prstGeom>
           <a:solidFill>
-            <a:srgbClr val="D2D7E9"/>
+            <a:srgbClr val="EEF0F7"/>
           </a:solidFill>
           <a:ln w="12700">
             <a:solidFill>
@@ -4332,7 +4332,7 @@
             <a:avLst/>
           </a:prstGeom>
           <a:solidFill>
-            <a:srgbClr val="D2D7E9"/>
+            <a:srgbClr val="EEF0F7"/>
           </a:solidFill>
           <a:ln w="12700">
             <a:solidFill>
@@ -4400,7 +4400,7 @@
             <a:avLst/>
           </a:prstGeom>
           <a:solidFill>
-            <a:srgbClr val="D2D7E9"/>
+            <a:srgbClr val="EEF0F7"/>
           </a:solidFill>
           <a:ln w="12700">
             <a:solidFill>
@@ -4468,7 +4468,7 @@
             <a:avLst/>
           </a:prstGeom>
           <a:solidFill>
-            <a:srgbClr val="D2D7E9"/>
+            <a:srgbClr val="EEF0F7"/>
           </a:solidFill>
           <a:ln w="12700">
             <a:solidFill>
@@ -4536,7 +4536,7 @@
             <a:avLst/>
           </a:prstGeom>
           <a:solidFill>
-            <a:srgbClr val="D2D7E9"/>
+            <a:srgbClr val="EEF0F7"/>
           </a:solidFill>
           <a:ln w="12700">
             <a:solidFill>
@@ -4604,7 +4604,7 @@
             <a:avLst/>
           </a:prstGeom>
           <a:solidFill>
-            <a:srgbClr val="EEEEEE"/>
+            <a:srgbClr val="F7F7F7"/>
           </a:solidFill>
           <a:ln w="12700">
             <a:solidFill>
@@ -4672,7 +4672,7 @@
             <a:avLst/>
           </a:prstGeom>
           <a:solidFill>
-            <a:srgbClr val="EEEEEE"/>
+            <a:srgbClr val="F7F7F7"/>
           </a:solidFill>
           <a:ln w="12700">
             <a:solidFill>
@@ -4740,7 +4740,7 @@
             <a:avLst/>
           </a:prstGeom>
           <a:solidFill>
-            <a:srgbClr val="EEEEEE"/>
+            <a:srgbClr val="F7F7F7"/>
           </a:solidFill>
           <a:ln w="12700">
             <a:solidFill>
@@ -4808,7 +4808,7 @@
             <a:avLst/>
           </a:prstGeom>
           <a:solidFill>
-            <a:srgbClr val="EEEEEE"/>
+            <a:srgbClr val="F7F7F7"/>
           </a:solidFill>
           <a:ln w="12700">
             <a:solidFill>
@@ -4876,7 +4876,7 @@
             <a:avLst/>
           </a:prstGeom>
           <a:solidFill>
-            <a:srgbClr val="EEEEEE"/>
+            <a:srgbClr val="F7F7F7"/>
           </a:solidFill>
           <a:ln w="12700">
             <a:solidFill>
@@ -4944,7 +4944,7 @@
             <a:avLst/>
           </a:prstGeom>
           <a:solidFill>
-            <a:srgbClr val="EEEEEE"/>
+            <a:srgbClr val="F7F7F7"/>
           </a:solidFill>
           <a:ln w="12700">
             <a:solidFill>
@@ -5012,7 +5012,7 @@
             <a:avLst/>
           </a:prstGeom>
           <a:solidFill>
-            <a:srgbClr val="D2D7E9"/>
+            <a:srgbClr val="EEF0F7"/>
           </a:solidFill>
           <a:ln w="12700">
             <a:solidFill>
@@ -5094,7 +5094,7 @@
             <a:avLst/>
           </a:prstGeom>
           <a:solidFill>
-            <a:srgbClr val="D2D7E9"/>
+            <a:srgbClr val="EEF0F7"/>
           </a:solidFill>
           <a:ln w="12700">
             <a:solidFill>
@@ -5176,7 +5176,7 @@
             <a:avLst/>
           </a:prstGeom>
           <a:solidFill>
-            <a:srgbClr val="D2D7E9"/>
+            <a:srgbClr val="EEF0F7"/>
           </a:solidFill>
           <a:ln w="12700">
             <a:solidFill>
@@ -5244,7 +5244,7 @@
             <a:avLst/>
           </a:prstGeom>
           <a:solidFill>
-            <a:srgbClr val="D2D7E9"/>
+            <a:srgbClr val="EEF0F7"/>
           </a:solidFill>
           <a:ln w="12700">
             <a:solidFill>
@@ -5312,7 +5312,7 @@
             <a:avLst/>
           </a:prstGeom>
           <a:solidFill>
-            <a:srgbClr val="D2D7E9"/>
+            <a:srgbClr val="EEF0F7"/>
           </a:solidFill>
           <a:ln w="12700">
             <a:solidFill>
@@ -5380,7 +5380,7 @@
             <a:avLst/>
           </a:prstGeom>
           <a:solidFill>
-            <a:srgbClr val="D2D7E9"/>
+            <a:srgbClr val="EEF0F7"/>
           </a:solidFill>
           <a:ln w="12700">
             <a:solidFill>
@@ -5448,7 +5448,7 @@
             <a:avLst/>
           </a:prstGeom>
           <a:solidFill>
-            <a:srgbClr val="EEEEEE"/>
+            <a:srgbClr val="F7F7F7"/>
           </a:solidFill>
           <a:ln w="12700">
             <a:solidFill>
@@ -5530,7 +5530,7 @@
             <a:avLst/>
           </a:prstGeom>
           <a:solidFill>
-            <a:srgbClr val="EEEEEE"/>
+            <a:srgbClr val="F7F7F7"/>
           </a:solidFill>
           <a:ln w="12700">
             <a:solidFill>
@@ -5598,7 +5598,7 @@
             <a:avLst/>
           </a:prstGeom>
           <a:solidFill>
-            <a:srgbClr val="EEEEEE"/>
+            <a:srgbClr val="F7F7F7"/>
           </a:solidFill>
           <a:ln w="12700">
             <a:solidFill>
@@ -5680,7 +5680,7 @@
             <a:avLst/>
           </a:prstGeom>
           <a:solidFill>
-            <a:srgbClr val="EEEEEE"/>
+            <a:srgbClr val="F7F7F7"/>
           </a:solidFill>
           <a:ln w="12700">
             <a:solidFill>
@@ -5762,7 +5762,7 @@
             <a:avLst/>
           </a:prstGeom>
           <a:solidFill>
-            <a:srgbClr val="EEEEEE"/>
+            <a:srgbClr val="F7F7F7"/>
           </a:solidFill>
           <a:ln w="12700">
             <a:solidFill>
@@ -5844,7 +5844,7 @@
             <a:avLst/>
           </a:prstGeom>
           <a:solidFill>
-            <a:srgbClr val="EEEEEE"/>
+            <a:srgbClr val="F7F7F7"/>
           </a:solidFill>
           <a:ln w="12700">
             <a:solidFill>
@@ -5926,7 +5926,7 @@
             <a:avLst/>
           </a:prstGeom>
           <a:solidFill>
-            <a:srgbClr val="D9F3D0"/>
+            <a:srgbClr val="EFF9EC"/>
           </a:solidFill>
           <a:ln w="12700">
             <a:solidFill>
@@ -5994,7 +5994,7 @@
             <a:avLst/>
           </a:prstGeom>
           <a:solidFill>
-            <a:srgbClr val="D9F3D0"/>
+            <a:srgbClr val="EFF9EC"/>
           </a:solidFill>
           <a:ln w="12700">
             <a:solidFill>
@@ -6054,7 +6054,7 @@
             <a:avLst/>
           </a:prstGeom>
           <a:solidFill>
-            <a:srgbClr val="D9F3D0"/>
+            <a:srgbClr val="EFF9EC"/>
           </a:solidFill>
           <a:ln w="12700">
             <a:solidFill>
@@ -6122,7 +6122,7 @@
             <a:avLst/>
           </a:prstGeom>
           <a:solidFill>
-            <a:srgbClr val="D9F3D0"/>
+            <a:srgbClr val="EFF9EC"/>
           </a:solidFill>
           <a:ln w="12700">
             <a:solidFill>
@@ -6190,7 +6190,7 @@
             <a:avLst/>
           </a:prstGeom>
           <a:solidFill>
-            <a:srgbClr val="D9F3D0"/>
+            <a:srgbClr val="EFF9EC"/>
           </a:solidFill>
           <a:ln w="12700">
             <a:solidFill>
@@ -6258,7 +6258,7 @@
             <a:avLst/>
           </a:prstGeom>
           <a:solidFill>
-            <a:srgbClr val="D9F3D0"/>
+            <a:srgbClr val="EFF9EC"/>
           </a:solidFill>
           <a:ln w="12700">
             <a:solidFill>
@@ -6591,7 +6591,7 @@
             <a:avLst/>
           </a:prstGeom>
           <a:solidFill>
-            <a:srgbClr val="D9F3D0"/>
+            <a:srgbClr val="EFF9EC"/>
           </a:solidFill>
           <a:ln w="12700">
             <a:solidFill>
@@ -6695,7 +6695,7 @@
             <a:avLst/>
           </a:prstGeom>
           <a:solidFill>
-            <a:srgbClr val="DEF3CF"/>
+            <a:srgbClr val="F1F9EC"/>
           </a:solidFill>
           <a:ln/>
         </p:spPr>
@@ -6758,7 +6758,7 @@
             <a:avLst/>
           </a:prstGeom>
           <a:solidFill>
-            <a:srgbClr val="D9F3D0"/>
+            <a:srgbClr val="EFF9EC"/>
           </a:solidFill>
           <a:ln w="12700">
             <a:solidFill>
@@ -6862,7 +6862,7 @@
             <a:avLst/>
           </a:prstGeom>
           <a:solidFill>
-            <a:srgbClr val="DEF3CF"/>
+            <a:srgbClr val="F1F9EC"/>
           </a:solidFill>
           <a:ln/>
         </p:spPr>
@@ -6925,7 +6925,7 @@
             <a:avLst/>
           </a:prstGeom>
           <a:solidFill>
-            <a:srgbClr val="D9F3D0"/>
+            <a:srgbClr val="EFF9EC"/>
           </a:solidFill>
           <a:ln w="12700">
             <a:solidFill>
@@ -7029,7 +7029,7 @@
             <a:avLst/>
           </a:prstGeom>
           <a:solidFill>
-            <a:srgbClr val="DEF3CF"/>
+            <a:srgbClr val="F1F9EC"/>
           </a:solidFill>
           <a:ln/>
         </p:spPr>
@@ -7158,7 +7158,7 @@
             <a:avLst/>
           </a:prstGeom>
           <a:solidFill>
-            <a:srgbClr val="F4DFD2"/>
+            <a:srgbClr val="F9F1EC"/>
           </a:solidFill>
           <a:ln w="12700">
             <a:solidFill>
@@ -7262,7 +7262,7 @@
             <a:avLst/>
           </a:prstGeom>
           <a:solidFill>
-            <a:srgbClr val="F3DDCF"/>
+            <a:srgbClr val="F9F1EC"/>
           </a:solidFill>
           <a:ln/>
         </p:spPr>
@@ -7325,7 +7325,7 @@
             <a:avLst/>
           </a:prstGeom>
           <a:solidFill>
-            <a:srgbClr val="F4DFD2"/>
+            <a:srgbClr val="F9F1EC"/>
           </a:solidFill>
           <a:ln w="12700">
             <a:solidFill>
@@ -7429,7 +7429,7 @@
             <a:avLst/>
           </a:prstGeom>
           <a:solidFill>
-            <a:srgbClr val="F3DDCF"/>
+            <a:srgbClr val="F9F1EC"/>
           </a:solidFill>
           <a:ln/>
         </p:spPr>
@@ -7492,7 +7492,7 @@
             <a:avLst/>
           </a:prstGeom>
           <a:solidFill>
-            <a:srgbClr val="F4DFD2"/>
+            <a:srgbClr val="F9F1EC"/>
           </a:solidFill>
           <a:ln w="12700">
             <a:solidFill>
@@ -7596,7 +7596,7 @@
             <a:avLst/>
           </a:prstGeom>
           <a:solidFill>
-            <a:srgbClr val="F3DDCF"/>
+            <a:srgbClr val="F9F1EC"/>
           </a:solidFill>
           <a:ln/>
         </p:spPr>
@@ -7659,7 +7659,7 @@
             <a:avLst/>
           </a:prstGeom>
           <a:solidFill>
-            <a:srgbClr val="F3F3D1"/>
+            <a:srgbClr val="F9F9EC"/>
           </a:solidFill>
           <a:ln/>
         </p:spPr>
@@ -8029,7 +8029,7 @@
             <a:avLst/>
           </a:prstGeom>
           <a:solidFill>
-            <a:srgbClr val="D6D6D6"/>
+            <a:srgbClr val="F7F7F7"/>
           </a:solidFill>
           <a:ln>
             <a:noFill/>
@@ -8747,7 +8747,7 @@
             <a:avLst/>
           </a:prstGeom>
           <a:solidFill>
-            <a:srgbClr val="EEEEEE"/>
+            <a:srgbClr val="F7F7F7"/>
           </a:solidFill>
           <a:ln w="12700">
             <a:solidFill>
@@ -8851,7 +8851,7 @@
             <a:avLst/>
           </a:prstGeom>
           <a:solidFill>
-            <a:srgbClr val="EEEEEE"/>
+            <a:srgbClr val="F7F7F7"/>
           </a:solidFill>
           <a:ln w="12700">
             <a:solidFill>
@@ -8955,7 +8955,7 @@
             <a:avLst/>
           </a:prstGeom>
           <a:solidFill>
-            <a:srgbClr val="EEEEEE"/>
+            <a:srgbClr val="F7F7F7"/>
           </a:solidFill>
           <a:ln w="12700">
             <a:solidFill>
@@ -9059,7 +9059,7 @@
             <a:avLst/>
           </a:prstGeom>
           <a:solidFill>
-            <a:srgbClr val="EEEEEE"/>
+            <a:srgbClr val="F7F7F7"/>
           </a:solidFill>
           <a:ln w="12700">
             <a:solidFill>
@@ -9163,7 +9163,7 @@
             <a:avLst/>
           </a:prstGeom>
           <a:solidFill>
-            <a:srgbClr val="EEEEEE"/>
+            <a:srgbClr val="F7F7F7"/>
           </a:solidFill>
           <a:ln w="12700">
             <a:solidFill>
@@ -9267,7 +9267,7 @@
             <a:avLst/>
           </a:prstGeom>
           <a:solidFill>
-            <a:srgbClr val="EEEEEE"/>
+            <a:srgbClr val="F7F7F7"/>
           </a:solidFill>
           <a:ln w="12700">
             <a:solidFill>
@@ -9566,7 +9566,7 @@
             <a:avLst/>
           </a:prstGeom>
           <a:solidFill>
-            <a:srgbClr val="EEEEEE"/>
+            <a:srgbClr val="F7F7F7"/>
           </a:solidFill>
           <a:ln w="12700">
             <a:solidFill>
@@ -9690,7 +9690,7 @@
             <a:avLst/>
           </a:prstGeom>
           <a:solidFill>
-            <a:srgbClr val="EEEEEE"/>
+            <a:srgbClr val="F7F7F7"/>
           </a:solidFill>
           <a:ln w="12700">
             <a:solidFill>
@@ -9890,7 +9890,7 @@
             <a:avLst/>
           </a:prstGeom>
           <a:solidFill>
-            <a:srgbClr val="EDEDED"/>
+            <a:srgbClr val="F7F7F7"/>
           </a:solidFill>
           <a:ln>
             <a:noFill/>
@@ -10198,7 +10198,7 @@
             <a:avLst/>
           </a:prstGeom>
           <a:solidFill>
-            <a:srgbClr val="EEEEEE"/>
+            <a:srgbClr val="F7F7F7"/>
           </a:solidFill>
           <a:ln w="12700">
             <a:solidFill>
@@ -10302,7 +10302,7 @@
             <a:avLst/>
           </a:prstGeom>
           <a:solidFill>
-            <a:srgbClr val="EBEBEB"/>
+            <a:srgbClr val="F7F7F7"/>
           </a:solidFill>
           <a:ln w="12700">
             <a:solidFill>
@@ -10406,7 +10406,7 @@
             <a:avLst/>
           </a:prstGeom>
           <a:solidFill>
-            <a:srgbClr val="EEEEEE"/>
+            <a:srgbClr val="F7F7F7"/>
           </a:solidFill>
           <a:ln w="12700">
             <a:solidFill>
@@ -10438,7 +10438,7 @@
             <a:avLst/>
           </a:prstGeom>
           <a:solidFill>
-            <a:srgbClr val="EEEEEE"/>
+            <a:srgbClr val="F7F7F7"/>
           </a:solidFill>
           <a:ln w="12700">
             <a:solidFill>
@@ -10542,7 +10542,7 @@
             <a:avLst/>
           </a:prstGeom>
           <a:solidFill>
-            <a:srgbClr val="EBEBEB"/>
+            <a:srgbClr val="F7F7F7"/>
           </a:solidFill>
           <a:ln w="12700">
             <a:solidFill>
@@ -10646,7 +10646,7 @@
             <a:avLst/>
           </a:prstGeom>
           <a:solidFill>
-            <a:srgbClr val="EEEEEE"/>
+            <a:srgbClr val="F7F7F7"/>
           </a:solidFill>
           <a:ln w="12700">
             <a:solidFill>
@@ -10750,7 +10750,7 @@
             <a:avLst/>
           </a:prstGeom>
           <a:solidFill>
-            <a:srgbClr val="EBEBEB"/>
+            <a:srgbClr val="F7F7F7"/>
           </a:solidFill>
           <a:ln w="12700">
             <a:solidFill>
@@ -10854,7 +10854,7 @@
             <a:avLst/>
           </a:prstGeom>
           <a:solidFill>
-            <a:srgbClr val="F3DDCF"/>
+            <a:srgbClr val="F9F1EC"/>
           </a:solidFill>
           <a:ln w="12700">
             <a:solidFill>
@@ -11208,7 +11208,7 @@
             <a:avLst/>
           </a:prstGeom>
           <a:solidFill>
-            <a:srgbClr val="EDEDED"/>
+            <a:srgbClr val="F7F7F7"/>
           </a:solidFill>
           <a:ln>
             <a:noFill/>
@@ -11471,7 +11471,7 @@
             <a:avLst/>
           </a:prstGeom>
           <a:solidFill>
-            <a:srgbClr val="D6D6D6"/>
+            <a:srgbClr val="F7F7F7"/>
           </a:solidFill>
           <a:ln>
             <a:noFill/>
@@ -12373,7 +12373,7 @@
             <a:avLst/>
           </a:prstGeom>
           <a:solidFill>
-            <a:srgbClr val="EDEDED"/>
+            <a:srgbClr val="F7F7F7"/>
           </a:solidFill>
           <a:ln>
             <a:noFill/>
@@ -12671,7 +12671,7 @@
             <a:avLst/>
           </a:prstGeom>
           <a:solidFill>
-            <a:srgbClr val="D6D6D6"/>
+            <a:srgbClr val="F7F7F7"/>
           </a:solidFill>
           <a:ln>
             <a:noFill/>
@@ -13065,7 +13065,7 @@
             <a:avLst/>
           </a:prstGeom>
           <a:solidFill>
-            <a:srgbClr val="D6D6D6"/>
+            <a:srgbClr val="F7F7F7"/>
           </a:solidFill>
           <a:ln>
             <a:noFill/>
@@ -13179,7 +13179,7 @@
             <a:avLst/>
           </a:prstGeom>
           <a:solidFill>
-            <a:srgbClr val="F3E5CF"/>
+            <a:srgbClr val="F9F4EC"/>
           </a:solidFill>
           <a:ln>
             <a:noFill/>
@@ -13267,7 +13267,7 @@
             <a:avLst/>
           </a:prstGeom>
           <a:solidFill>
-            <a:srgbClr val="F4DFD2"/>
+            <a:srgbClr val="F9F1EC"/>
           </a:solidFill>
           <a:ln>
             <a:noFill/>
@@ -13600,7 +13600,7 @@
             <a:avLst/>
           </a:prstGeom>
           <a:solidFill>
-            <a:srgbClr val="F3E4CF"/>
+            <a:srgbClr val="F9F3EC"/>
           </a:solidFill>
           <a:ln w="9525">
             <a:solidFill>
@@ -13724,7 +13724,7 @@
             <a:avLst/>
           </a:prstGeom>
           <a:solidFill>
-            <a:srgbClr val="EDEDED"/>
+            <a:srgbClr val="F7F7F7"/>
           </a:solidFill>
           <a:ln>
             <a:noFill/>
@@ -13992,7 +13992,7 @@
             <a:avLst/>
           </a:prstGeom>
           <a:solidFill>
-            <a:srgbClr val="EDEDED"/>
+            <a:srgbClr val="F7F7F7"/>
           </a:solidFill>
           <a:ln>
             <a:noFill/>
@@ -14080,7 +14080,7 @@
             <a:avLst/>
           </a:prstGeom>
           <a:solidFill>
-            <a:srgbClr val="EFEFEF"/>
+            <a:srgbClr val="F7F7F7"/>
           </a:solidFill>
           <a:ln>
             <a:noFill/>
@@ -14375,7 +14375,7 @@
             <a:avLst/>
           </a:prstGeom>
           <a:solidFill>
-            <a:srgbClr val="EDEDED"/>
+            <a:srgbClr val="F7F7F7"/>
           </a:solidFill>
           <a:ln>
             <a:noFill/>
@@ -14463,7 +14463,7 @@
             <a:avLst/>
           </a:prstGeom>
           <a:solidFill>
-            <a:srgbClr val="EFEFEF"/>
+            <a:srgbClr val="F7F7F7"/>
           </a:solidFill>
           <a:ln>
             <a:noFill/>
@@ -14747,7 +14747,7 @@
             <a:avLst/>
           </a:prstGeom>
           <a:solidFill>
-            <a:srgbClr val="EDEDED"/>
+            <a:srgbClr val="F7F7F7"/>
           </a:solidFill>
           <a:ln>
             <a:noFill/>
@@ -14835,7 +14835,7 @@
             <a:avLst/>
           </a:prstGeom>
           <a:solidFill>
-            <a:srgbClr val="EFEFEF"/>
+            <a:srgbClr val="F7F7F7"/>
           </a:solidFill>
           <a:ln>
             <a:noFill/>
@@ -15130,7 +15130,7 @@
             <a:avLst/>
           </a:prstGeom>
           <a:solidFill>
-            <a:srgbClr val="EDEDED"/>
+            <a:srgbClr val="F7F7F7"/>
           </a:solidFill>
           <a:ln>
             <a:noFill/>
@@ -15218,7 +15218,7 @@
             <a:avLst/>
           </a:prstGeom>
           <a:solidFill>
-            <a:srgbClr val="EFEFEF"/>
+            <a:srgbClr val="F7F7F7"/>
           </a:solidFill>
           <a:ln>
             <a:noFill/>
@@ -15491,7 +15491,7 @@
             <a:avLst/>
           </a:prstGeom>
           <a:solidFill>
-            <a:srgbClr val="F4DFD2"/>
+            <a:srgbClr val="F9F1EC"/>
           </a:solidFill>
           <a:ln>
             <a:noFill/>
@@ -15673,7 +15673,7 @@
             <a:avLst/>
           </a:prstGeom>
           <a:solidFill>
-            <a:srgbClr val="F5F5F5"/>
+            <a:srgbClr val="F7F7F7"/>
           </a:solidFill>
           <a:ln>
             <a:noFill/>
@@ -15761,7 +15761,7 @@
             <a:avLst/>
           </a:prstGeom>
           <a:solidFill>
-            <a:srgbClr val="EDEDED"/>
+            <a:srgbClr val="F7F7F7"/>
           </a:solidFill>
           <a:ln>
             <a:noFill/>
@@ -15875,7 +15875,7 @@
             <a:avLst/>
           </a:prstGeom>
           <a:solidFill>
-            <a:srgbClr val="EDEDED"/>
+            <a:srgbClr val="F7F7F7"/>
           </a:solidFill>
           <a:ln>
             <a:noFill/>
@@ -15919,7 +15919,7 @@
             <a:avLst/>
           </a:prstGeom>
           <a:solidFill>
-            <a:srgbClr val="F4DFD2"/>
+            <a:srgbClr val="F9F1EC"/>
           </a:solidFill>
           <a:ln>
             <a:noFill/>
@@ -15963,7 +15963,7 @@
             <a:avLst/>
           </a:prstGeom>
           <a:solidFill>
-            <a:srgbClr val="EDDAB6"/>
+            <a:srgbClr val="F9F4EC"/>
           </a:solidFill>
           <a:ln>
             <a:noFill/>
@@ -16186,7 +16186,7 @@
             <a:avLst/>
           </a:prstGeom>
           <a:solidFill>
-            <a:srgbClr val="EFEFEF"/>
+            <a:srgbClr val="F7F7F7"/>
           </a:solidFill>
           <a:ln>
             <a:noFill/>
@@ -16633,7 +16633,7 @@
             <a:avLst/>
           </a:prstGeom>
           <a:solidFill>
-            <a:srgbClr val="E6E6E6"/>
+            <a:srgbClr val="F7F7F7"/>
           </a:solidFill>
           <a:ln w="12700">
             <a:solidFill>
@@ -16803,7 +16803,7 @@
             <a:avLst/>
           </a:prstGeom>
           <a:solidFill>
-            <a:srgbClr val="E6E6E6"/>
+            <a:srgbClr val="F7F7F7"/>
           </a:solidFill>
           <a:ln w="12700">
             <a:solidFill>
@@ -16973,7 +16973,7 @@
             <a:avLst/>
           </a:prstGeom>
           <a:solidFill>
-            <a:srgbClr val="E6E6E6"/>
+            <a:srgbClr val="F7F7F7"/>
           </a:solidFill>
           <a:ln w="12700">
             <a:solidFill>
@@ -17113,7 +17113,7 @@
             <a:avLst/>
           </a:prstGeom>
           <a:solidFill>
-            <a:srgbClr val="E6E6E6"/>
+            <a:srgbClr val="F7F7F7"/>
           </a:solidFill>
           <a:ln w="12700">
             <a:solidFill>
@@ -17253,7 +17253,7 @@
             <a:avLst/>
           </a:prstGeom>
           <a:solidFill>
-            <a:srgbClr val="F3DDCF"/>
+            <a:srgbClr val="F9F1EC"/>
           </a:solidFill>
           <a:ln w="12700">
             <a:solidFill>
@@ -17468,7 +17468,7 @@
             <a:avLst/>
           </a:prstGeom>
           <a:solidFill>
-            <a:srgbClr val="EDEDED"/>
+            <a:srgbClr val="F7F7F7"/>
           </a:solidFill>
           <a:ln w="12700">
             <a:solidFill>
@@ -17877,7 +17877,7 @@
             <a:avLst/>
           </a:prstGeom>
           <a:solidFill>
-            <a:srgbClr val="EDEDED"/>
+            <a:srgbClr val="F7F7F7"/>
           </a:solidFill>
           <a:ln w="12700">
             <a:solidFill>
@@ -18017,7 +18017,7 @@
             <a:avLst/>
           </a:prstGeom>
           <a:solidFill>
-            <a:srgbClr val="EDEDED"/>
+            <a:srgbClr val="F7F7F7"/>
           </a:solidFill>
           <a:ln w="12700">
             <a:solidFill>
@@ -18157,7 +18157,7 @@
             <a:avLst/>
           </a:prstGeom>
           <a:solidFill>
-            <a:srgbClr val="EDEDED"/>
+            <a:srgbClr val="F7F7F7"/>
           </a:solidFill>
           <a:ln w="12700">
             <a:solidFill>
@@ -18297,7 +18297,7 @@
             <a:avLst/>
           </a:prstGeom>
           <a:solidFill>
-            <a:srgbClr val="F4E9D2"/>
+            <a:srgbClr val="F9F5EC"/>
           </a:solidFill>
           <a:ln w="12700">
             <a:solidFill>
@@ -18573,7 +18573,7 @@
             <a:avLst/>
           </a:prstGeom>
           <a:solidFill>
-            <a:srgbClr val="EBEBEB"/>
+            <a:srgbClr val="F7F7F7"/>
           </a:solidFill>
           <a:ln>
             <a:noFill/>
@@ -18617,7 +18617,7 @@
             <a:avLst/>
           </a:prstGeom>
           <a:solidFill>
-            <a:srgbClr val="EBEBEB"/>
+            <a:srgbClr val="F7F7F7"/>
           </a:solidFill>
           <a:ln>
             <a:noFill/>
@@ -18661,7 +18661,7 @@
             <a:avLst/>
           </a:prstGeom>
           <a:solidFill>
-            <a:srgbClr val="EFEFEF"/>
+            <a:srgbClr val="F7F7F7"/>
           </a:solidFill>
           <a:ln>
             <a:noFill/>
@@ -18705,7 +18705,7 @@
             <a:avLst/>
           </a:prstGeom>
           <a:solidFill>
-            <a:srgbClr val="EFEFEF"/>
+            <a:srgbClr val="F7F7F7"/>
           </a:solidFill>
           <a:ln>
             <a:noFill/>
@@ -20277,7 +20277,7 @@
             <a:avLst/>
           </a:prstGeom>
           <a:solidFill>
-            <a:srgbClr val="F5F5F5"/>
+            <a:srgbClr val="F7F7F7"/>
           </a:solidFill>
           <a:ln>
             <a:noFill/>
@@ -20365,7 +20365,7 @@
             <a:avLst/>
           </a:prstGeom>
           <a:solidFill>
-            <a:srgbClr val="EDEDED"/>
+            <a:srgbClr val="F7F7F7"/>
           </a:solidFill>
           <a:ln>
             <a:noFill/>
@@ -22448,7 +22448,7 @@
             <a:avLst/>
           </a:prstGeom>
           <a:solidFill>
-            <a:srgbClr val="EDEDED"/>
+            <a:srgbClr val="F7F7F7"/>
           </a:solidFill>
           <a:ln>
             <a:noFill/>
@@ -23114,7 +23114,7 @@
             <a:avLst/>
           </a:prstGeom>
           <a:solidFill>
-            <a:srgbClr val="F5F5F5"/>
+            <a:srgbClr val="F7F7F7"/>
           </a:solidFill>
           <a:ln>
             <a:noFill/>
@@ -23202,7 +23202,7 @@
             <a:avLst/>
           </a:prstGeom>
           <a:solidFill>
-            <a:srgbClr val="EEBEBE"/>
+            <a:srgbClr val="F9ECEC"/>
           </a:solidFill>
           <a:ln>
             <a:noFill/>
@@ -23245,7 +23245,7 @@
             <a:avLst/>
           </a:prstGeom>
           <a:solidFill>
-            <a:srgbClr val="EEBEBE"/>
+            <a:srgbClr val="F9ECEC"/>
           </a:solidFill>
           <a:ln>
             <a:noFill/>
@@ -23288,7 +23288,7 @@
             <a:avLst/>
           </a:prstGeom>
           <a:solidFill>
-            <a:srgbClr val="EDEDED"/>
+            <a:srgbClr val="F7F7F7"/>
           </a:solidFill>
           <a:ln>
             <a:noFill/>
@@ -24552,7 +24552,7 @@
             <a:avLst/>
           </a:prstGeom>
           <a:solidFill>
-            <a:srgbClr val="EDEDED"/>
+            <a:srgbClr val="F7F7F7"/>
           </a:solidFill>
           <a:ln>
             <a:noFill/>
@@ -26603,7 +26603,7 @@
             <a:avLst/>
           </a:prstGeom>
           <a:solidFill>
-            <a:srgbClr val="F5F5F5"/>
+            <a:srgbClr val="F7F7F7"/>
           </a:solidFill>
           <a:ln>
             <a:noFill/>
@@ -26691,7 +26691,7 @@
             <a:avLst/>
           </a:prstGeom>
           <a:solidFill>
-            <a:srgbClr val="EDEDED"/>
+            <a:srgbClr val="F7F7F7"/>
           </a:solidFill>
           <a:ln>
             <a:noFill/>
@@ -26770,7 +26770,7 @@
             <a:avLst/>
           </a:prstGeom>
           <a:solidFill>
-            <a:srgbClr val="D6D6D6"/>
+            <a:srgbClr val="F7F7F7"/>
           </a:solidFill>
           <a:ln>
             <a:noFill/>
@@ -27797,7 +27797,7 @@
             <a:avLst/>
           </a:prstGeom>
           <a:solidFill>
-            <a:srgbClr val="EDEDED"/>
+            <a:srgbClr val="F7F7F7"/>
           </a:solidFill>
           <a:ln>
             <a:noFill/>
@@ -28059,7 +28059,7 @@
             <a:avLst/>
           </a:prstGeom>
           <a:solidFill>
-            <a:srgbClr val="F3E4CF"/>
+            <a:srgbClr val="F9F3EC"/>
           </a:solidFill>
           <a:ln w="9525">
             <a:solidFill>
@@ -28345,7 +28345,7 @@
             <a:avLst/>
           </a:prstGeom>
           <a:solidFill>
-            <a:srgbClr val="F5F5F5"/>
+            <a:srgbClr val="F7F7F7"/>
           </a:solidFill>
           <a:ln>
             <a:noFill/>
@@ -28433,7 +28433,7 @@
             <a:avLst/>
           </a:prstGeom>
           <a:solidFill>
-            <a:srgbClr val="EDEDED"/>
+            <a:srgbClr val="F7F7F7"/>
           </a:solidFill>
           <a:ln>
             <a:noFill/>
@@ -28512,7 +28512,7 @@
             <a:avLst/>
           </a:prstGeom>
           <a:solidFill>
-            <a:srgbClr val="D6D6D6"/>
+            <a:srgbClr val="F7F7F7"/>
           </a:solidFill>
           <a:ln>
             <a:noFill/>
@@ -28731,7 +28731,7 @@
             <a:avLst/>
           </a:prstGeom>
           <a:solidFill>
-            <a:srgbClr val="D6D6D6"/>
+            <a:srgbClr val="F7F7F7"/>
           </a:solidFill>
           <a:ln>
             <a:noFill/>
@@ -29790,7 +29790,7 @@
             <a:avLst/>
           </a:prstGeom>
           <a:solidFill>
-            <a:srgbClr val="F3E4CF"/>
+            <a:srgbClr val="F9F3EC"/>
           </a:solidFill>
           <a:ln>
             <a:noFill/>
@@ -29834,7 +29834,7 @@
             <a:avLst/>
           </a:prstGeom>
           <a:solidFill>
-            <a:srgbClr val="EDDAB6"/>
+            <a:srgbClr val="F9F4EC"/>
           </a:solidFill>
           <a:ln>
             <a:noFill/>
@@ -30208,7 +30208,7 @@
             <a:avLst/>
           </a:prstGeom>
           <a:solidFill>
-            <a:srgbClr val="D5EFD5"/>
+            <a:srgbClr val="EDF8ED"/>
           </a:solidFill>
           <a:ln>
             <a:noFill/>
@@ -30252,7 +30252,7 @@
             <a:avLst/>
           </a:prstGeom>
           <a:solidFill>
-            <a:srgbClr val="F1D3D3"/>
+            <a:srgbClr val="F9ECEC"/>
           </a:solidFill>
           <a:ln>
             <a:noFill/>
@@ -30296,7 +30296,7 @@
             <a:avLst/>
           </a:prstGeom>
           <a:solidFill>
-            <a:srgbClr val="C3E6C3"/>
+            <a:srgbClr val="EDF7ED"/>
           </a:solidFill>
           <a:ln>
             <a:noFill/>
@@ -30340,7 +30340,7 @@
             <a:avLst/>
           </a:prstGeom>
           <a:solidFill>
-            <a:srgbClr val="D6D6D6"/>
+            <a:srgbClr val="F7F7F7"/>
           </a:solidFill>
           <a:ln>
             <a:noFill/>
@@ -31706,7 +31706,7 @@
             <a:avLst/>
           </a:prstGeom>
           <a:solidFill>
-            <a:srgbClr val="E6E6E6"/>
+            <a:srgbClr val="F7F7F7"/>
           </a:solidFill>
           <a:ln w="12700">
             <a:solidFill>
@@ -31810,7 +31810,7 @@
             <a:avLst/>
           </a:prstGeom>
           <a:solidFill>
-            <a:srgbClr val="EBEBEB"/>
+            <a:srgbClr val="F7F7F7"/>
           </a:solidFill>
           <a:ln w="12700">
             <a:solidFill>
@@ -31914,7 +31914,7 @@
             <a:avLst/>
           </a:prstGeom>
           <a:solidFill>
-            <a:srgbClr val="EBEBEB"/>
+            <a:srgbClr val="F7F7F7"/>
           </a:solidFill>
           <a:ln w="12700">
             <a:solidFill>
@@ -32018,7 +32018,7 @@
             <a:avLst/>
           </a:prstGeom>
           <a:solidFill>
-            <a:srgbClr val="F3E4CF"/>
+            <a:srgbClr val="F9F3EC"/>
           </a:solidFill>
           <a:ln w="12700">
             <a:solidFill>
@@ -32122,7 +32122,7 @@
             <a:avLst/>
           </a:prstGeom>
           <a:solidFill>
-            <a:srgbClr val="ECECEC"/>
+            <a:srgbClr val="F7F7F7"/>
           </a:solidFill>
           <a:ln w="12700">
             <a:solidFill>
@@ -32226,7 +32226,7 @@
             <a:avLst/>
           </a:prstGeom>
           <a:solidFill>
-            <a:srgbClr val="D9F3D0"/>
+            <a:srgbClr val="EFF9EC"/>
           </a:solidFill>
           <a:ln w="12700">
             <a:solidFill>

</xml_diff>